<commit_message>
docs(deck): regenerate slides, guide and sample session with events.json
Sample session 20260916-173512_C12-S07 replaces 20260916-132318_C12-S07 (kept in history).

Co-Authored-By: Claude Fable 5.1 <noreply@anthropic.com>
</commit_message>
<xml_diff>
--- a/docs/deck/ExamEye-overview.pptx
+++ b/docs/deck/ExamEye-overview.pptx
@@ -5189,7 +5189,7 @@
                 <a:ea typeface="Courier New" pitchFamily="34" charset="-122"/>
                 <a:cs typeface="Courier New" pitchFamily="34" charset="-120"/>
               </a:rPr>
-              <a:t>events.jsonl</a:t>
+              <a:t>events.json</a:t>
             </a:r>
             <a:endParaRPr lang="en-US" sz="1150" dirty="0"/>
           </a:p>
@@ -8420,7 +8420,7 @@
                 <a:ea typeface="Courier New" pitchFamily="34" charset="-122"/>
                 <a:cs typeface="Courier New" pitchFamily="34" charset="-120"/>
               </a:rPr>
-              <a:t>OK 20260916-132318_C12-S07:</a:t>
+              <a:t>OK 20260916-173512_C12-S07:</a:t>
             </a:r>
             <a:endParaRPr lang="en-US" sz="1000" dirty="0"/>
           </a:p>
@@ -8437,7 +8437,7 @@
                 <a:ea typeface="Courier New" pitchFamily="34" charset="-122"/>
                 <a:cs typeface="Courier New" pitchFamily="34" charset="-120"/>
               </a:rPr>
-              <a:t>10 lines, 9 events, 3 screenshots present</a:t>
+              <a:t>12 lines, 11 events, 4 screenshots present</a:t>
             </a:r>
             <a:endParaRPr lang="en-US" sz="1000" dirty="0"/>
           </a:p>

</xml_diff>